<commit_message>
实验情况介绍.pptx: add incremental slide for segment-9-excluded results
New slide 十五 (after the comparison slide): 16-segment recomputation with
segment 9 removed, as an additive sensitivity check.
- Table: chi2_red 5.424->2.684, Birge 2.329->1.638, Bayesian u 0.800->0.546,
  Bayesian centre deviation vs experiment WLS -0.016->-0.928 (1e-18)
- Takeaway: axis consistency improves, but four-method centres shift down
  ~-0.6..-0.9e-18 and the tidal-compensation chi2_red advantage reverses
  (17 seg -31.8% -> 16 seg +5.1%); 17-segment result retained
Existing slides unchanged; trailing '问题' slide renumbered to 十六.
</commit_message>
<xml_diff>
--- a/docs/实验情况介绍.pptx
+++ b/docs/实验情况介绍.pptx
@@ -23,6 +23,7 @@
     <p:sldId id="271" r:id="rId22"/>
     <p:sldId id="272" r:id="rId23"/>
     <p:sldId id="273" r:id="rId24"/>
+    <p:sldId id="275" r:id="rId26"/>
     <p:sldId id="274" r:id="rId25"/>
   </p:sldIdLst>
   <p:sldSz cx="12191695" cy="6858000" type="screen4x3"/>
@@ -7312,8 +7313,8 @@
         </p:nvSpPr>
         <p:spPr>
           <a:xfrm>
-            <a:off x="640080" y="411480"/>
-            <a:ext cx="10911535" cy="822960"/>
+            <a:off x="640080" y="365760"/>
+            <a:ext cx="10908792" cy="822960"/>
           </a:xfrm>
           <a:prstGeom prst="rect">
             <a:avLst/>
@@ -7321,19 +7322,20 @@
           <a:noFill/>
         </p:spPr>
         <p:txBody>
-          <a:bodyPr wrap="square">
+          <a:bodyPr wrap="square" anchor="t">
             <a:spAutoFit/>
           </a:bodyPr>
           <a:lstStyle/>
           <a:p>
+            <a:pPr algn="l"/>
             <a:r>
               <a:rPr sz="3000" b="1">
                 <a:solidFill>
-                  <a:srgbClr val="1F3A5F"/>
-                </a:solidFill>
-                <a:latin typeface="Arial"/>
-              </a:rPr>
-              <a:t>十五、问题（待补充）</a:t>
+                  <a:srgbClr val="1F1F1F"/>
+                </a:solidFill>
+                <a:latin typeface="Arial"/>
+              </a:rPr>
+              <a:t>十五、增量分析：去掉第 9 段的计算结果</a:t>
             </a:r>
           </a:p>
         </p:txBody>
@@ -7346,37 +7348,8 @@
         </p:nvSpPr>
         <p:spPr>
           <a:xfrm>
-            <a:off x="658368" y="1188720"/>
-            <a:ext cx="10911535" cy="54864"/>
-          </a:xfrm>
-          <a:prstGeom prst="rect">
-            <a:avLst/>
-          </a:prstGeom>
-          <a:solidFill>
-            <a:srgbClr val="2E6DA4"/>
-          </a:solidFill>
-          <a:ln>
-            <a:noFill/>
-          </a:ln>
-        </p:spPr>
-        <p:txBody>
-          <a:bodyPr wrap="none">
-            <a:spAutoFit/>
-          </a:bodyPr>
-          <a:lstStyle/>
-          <a:p/>
-        </p:txBody>
-      </p:sp>
-      <p:sp>
-        <p:nvSpPr>
-          <p:cNvPr id="4" name="TextBox 3"/>
-          <p:cNvSpPr txBox="1"/>
-          <p:nvPr/>
-        </p:nvSpPr>
-        <p:spPr>
-          <a:xfrm>
-            <a:off x="658368" y="1243584"/>
-            <a:ext cx="10911535" cy="457200"/>
+            <a:off x="658368" y="1170432"/>
+            <a:ext cx="10908792" cy="54864"/>
           </a:xfrm>
           <a:prstGeom prst="rect">
             <a:avLst/>
@@ -7384,62 +7357,550 @@
           <a:noFill/>
         </p:spPr>
         <p:txBody>
-          <a:bodyPr wrap="square">
+          <a:bodyPr wrap="square" anchor="t">
             <a:spAutoFit/>
           </a:bodyPr>
           <a:lstStyle/>
           <a:p>
-            <a:r>
-              <a:rPr sz="1400" b="0">
-                <a:solidFill>
-                  <a:srgbClr val="8A8A8A"/>
-                </a:solidFill>
-                <a:latin typeface="Arial"/>
-              </a:rPr>
-              <a:t>（留空，后续补充）</a:t>
-            </a:r>
-          </a:p>
-        </p:txBody>
-      </p:sp>
-      <p:sp>
-        <p:nvSpPr>
-          <p:cNvPr id="5" name="TextBox 4"/>
+            <a:pPr algn="l"/>
+            <a:r>
+              <a:rPr sz="600" b="0">
+                <a:solidFill>
+                  <a:srgbClr val="606060"/>
+                </a:solidFill>
+                <a:latin typeface="Arial"/>
+              </a:rPr>
+              <a:t> </a:t>
+            </a:r>
+          </a:p>
+        </p:txBody>
+      </p:sp>
+      <p:sp>
+        <p:nvSpPr>
+          <p:cNvPr id="4" name="TextBox 3"/>
           <p:cNvSpPr txBox="1"/>
           <p:nvPr/>
         </p:nvSpPr>
         <p:spPr>
           <a:xfrm>
-            <a:off x="822960" y="2103120"/>
-            <a:ext cx="10545775" cy="3200400"/>
+            <a:off x="658368" y="1216152"/>
+            <a:ext cx="10908792" cy="457200"/>
           </a:xfrm>
           <a:prstGeom prst="rect">
             <a:avLst/>
           </a:prstGeom>
-          <a:solidFill>
-            <a:srgbClr val="F4F6F9"/>
-          </a:solidFill>
-          <a:ln>
-            <a:solidFill>
-              <a:srgbClr val="8A8A8A"/>
-            </a:solidFill>
-          </a:ln>
+          <a:noFill/>
         </p:spPr>
         <p:txBody>
-          <a:bodyPr wrap="square">
+          <a:bodyPr wrap="square" anchor="t">
             <a:spAutoFit/>
           </a:bodyPr>
           <a:lstStyle/>
-          <a:p/>
-          <a:p/>
-          <a:p>
-            <a:r>
-              <a:rPr sz="1600" b="0">
-                <a:solidFill>
-                  <a:srgbClr val="8A8A8A"/>
-                </a:solidFill>
-                <a:latin typeface="Arial"/>
-              </a:rPr>
-              <a:t>（本页留空，用于补充待解决的问题）</a:t>
+          <a:p>
+            <a:pPr algn="l"/>
+            <a:r>
+              <a:rPr sz="1400" b="0">
+                <a:solidFill>
+                  <a:srgbClr val="606060"/>
+                </a:solidFill>
+                <a:latin typeface="Arial"/>
+              </a:rPr>
+              <a:t>作为 17 段主结果的附加敏感性检验（附加结果，不替换主结果）</a:t>
+            </a:r>
+          </a:p>
+        </p:txBody>
+      </p:sp>
+      <p:sp>
+        <p:nvSpPr>
+          <p:cNvPr id="5" name="TextBox 4"/>
+          <p:cNvSpPr txBox="1"/>
+          <p:nvPr/>
+        </p:nvSpPr>
+        <p:spPr>
+          <a:xfrm>
+            <a:off x="731520" y="1737360"/>
+            <a:ext cx="10725912" cy="960120"/>
+          </a:xfrm>
+          <a:prstGeom prst="rect">
+            <a:avLst/>
+          </a:prstGeom>
+          <a:noFill/>
+        </p:spPr>
+        <p:txBody>
+          <a:bodyPr wrap="square" anchor="t">
+            <a:spAutoFit/>
+          </a:bodyPr>
+          <a:lstStyle/>
+          <a:p>
+            <a:pPr algn="l">
+              <a:lnSpc>
+                <a:spcPct val="105000"/>
+              </a:lnSpc>
+            </a:pPr>
+            <a:r>
+              <a:rPr sz="1450" b="0">
+                <a:solidFill>
+                  <a:srgbClr val="1F1F1F"/>
+                </a:solidFill>
+                <a:latin typeface="Arial"/>
+              </a:rPr>
+              <a:t>• 动机：第 9 段 shift_a 介于两轮之间（−8.13×10⁻¹⁷），y_9 为离群值（见方法 §8）</a:t>
+            </a:r>
+          </a:p>
+          <a:p>
+            <a:pPr algn="l">
+              <a:lnSpc>
+                <a:spcPct val="105000"/>
+              </a:lnSpc>
+            </a:pPr>
+            <a:r>
+              <a:rPr sz="1450" b="0">
+                <a:solidFill>
+                  <a:srgbClr val="1F1F1F"/>
+                </a:solidFill>
+                <a:latin typeface="Arial"/>
+              </a:rPr>
+              <a:t>• 方法：剔除第 9 段后，用既有逐段 (y_i, u_i) 重新合并（WLS / Birge / Mandel–Paule / 贝叶斯），不重选、不重修正</a:t>
+            </a:r>
+          </a:p>
+        </p:txBody>
+      </p:sp>
+      <p:graphicFrame>
+        <p:nvGraphicFramePr>
+          <p:cNvPr id="6" name="Table 5"/>
+          <p:cNvGraphicFramePr>
+            <a:graphicFrameLocks noGrp="1"/>
+          </p:cNvGraphicFramePr>
+          <p:nvPr/>
+        </p:nvGraphicFramePr>
+        <p:xfrm>
+          <a:off x="822960" y="2788920"/>
+          <a:ext cx="10515600" cy="1847088"/>
+        </p:xfrm>
+        <a:graphic>
+          <a:graphicData uri="http://schemas.openxmlformats.org/drawingml/2006/table">
+            <a:tbl>
+              <a:tblPr firstRow="1" bandRow="1">
+                <a:tableStyleId>{5C22544A-7EE6-4342-B048-85BDC9FD1C3A}</a:tableStyleId>
+              </a:tblPr>
+              <a:tblGrid>
+                <a:gridCol w="4846320"/>
+                <a:gridCol w="2834640"/>
+                <a:gridCol w="2834640"/>
+              </a:tblGrid>
+              <a:tr h="384048">
+                <a:tc>
+                  <a:txBody>
+                    <a:bodyPr wrap="square"/>
+                    <a:lstStyle/>
+                    <a:p>
+                      <a:pPr algn="l"/>
+                      <a:r>
+                        <a:rPr sz="1400" b="1">
+                          <a:solidFill>
+                            <a:srgbClr val="FFFFFF"/>
+                          </a:solidFill>
+                          <a:latin typeface="Arial"/>
+                        </a:rPr>
+                        <a:t>指标</a:t>
+                      </a:r>
+                    </a:p>
+                  </a:txBody>
+                  <a:tcPr anchor="ctr" marL="54864" marR="54864" marT="18288" marB="18288">
+                    <a:solidFill>
+                      <a:srgbClr val="2E6DA4"/>
+                    </a:solidFill>
+                  </a:tcPr>
+                </a:tc>
+                <a:tc>
+                  <a:txBody>
+                    <a:bodyPr wrap="square"/>
+                    <a:lstStyle/>
+                    <a:p>
+                      <a:pPr algn="ctr"/>
+                      <a:r>
+                        <a:rPr sz="1400" b="1">
+                          <a:solidFill>
+                            <a:srgbClr val="FFFFFF"/>
+                          </a:solidFill>
+                          <a:latin typeface="Arial"/>
+                        </a:rPr>
+                        <a:t>17 段（主结果）</a:t>
+                      </a:r>
+                    </a:p>
+                  </a:txBody>
+                  <a:tcPr anchor="ctr" marL="54864" marR="54864" marT="18288" marB="18288">
+                    <a:solidFill>
+                      <a:srgbClr val="2E6DA4"/>
+                    </a:solidFill>
+                  </a:tcPr>
+                </a:tc>
+                <a:tc>
+                  <a:txBody>
+                    <a:bodyPr wrap="square"/>
+                    <a:lstStyle/>
+                    <a:p>
+                      <a:pPr algn="ctr"/>
+                      <a:r>
+                        <a:rPr sz="1400" b="1">
+                          <a:solidFill>
+                            <a:srgbClr val="FFFFFF"/>
+                          </a:solidFill>
+                          <a:latin typeface="Arial"/>
+                        </a:rPr>
+                        <a:t>16 段（去第 9 段）</a:t>
+                      </a:r>
+                    </a:p>
+                  </a:txBody>
+                  <a:tcPr anchor="ctr" marL="54864" marR="54864" marT="18288" marB="18288">
+                    <a:solidFill>
+                      <a:srgbClr val="2E6DA4"/>
+                    </a:solidFill>
+                  </a:tcPr>
+                </a:tc>
+              </a:tr>
+              <a:tr h="365760">
+                <a:tc>
+                  <a:txBody>
+                    <a:bodyPr wrap="square"/>
+                    <a:lstStyle/>
+                    <a:p>
+                      <a:pPr algn="l"/>
+                      <a:r>
+                        <a:rPr sz="1300" b="1">
+                          <a:solidFill>
+                            <a:srgbClr val="1F1F1F"/>
+                          </a:solidFill>
+                          <a:latin typeface="Arial"/>
+                        </a:rPr>
+                        <a:t>χ²_red（raw）</a:t>
+                      </a:r>
+                    </a:p>
+                  </a:txBody>
+                  <a:tcPr anchor="ctr" marL="54864" marR="54864" marT="18288" marB="18288"/>
+                </a:tc>
+                <a:tc>
+                  <a:txBody>
+                    <a:bodyPr wrap="square"/>
+                    <a:lstStyle/>
+                    <a:p>
+                      <a:pPr algn="ctr"/>
+                      <a:r>
+                        <a:rPr sz="1300" b="0">
+                          <a:solidFill>
+                            <a:srgbClr val="1F1F1F"/>
+                          </a:solidFill>
+                          <a:latin typeface="Arial"/>
+                        </a:rPr>
+                        <a:t>5.424</a:t>
+                      </a:r>
+                    </a:p>
+                  </a:txBody>
+                  <a:tcPr anchor="ctr" marL="54864" marR="54864" marT="18288" marB="18288"/>
+                </a:tc>
+                <a:tc>
+                  <a:txBody>
+                    <a:bodyPr wrap="square"/>
+                    <a:lstStyle/>
+                    <a:p>
+                      <a:pPr algn="ctr"/>
+                      <a:r>
+                        <a:rPr sz="1300" b="0">
+                          <a:solidFill>
+                            <a:srgbClr val="1F1F1F"/>
+                          </a:solidFill>
+                          <a:latin typeface="Arial"/>
+                        </a:rPr>
+                        <a:t>2.684</a:t>
+                      </a:r>
+                    </a:p>
+                  </a:txBody>
+                  <a:tcPr anchor="ctr" marL="54864" marR="54864" marT="18288" marB="18288"/>
+                </a:tc>
+              </a:tr>
+              <a:tr h="365760">
+                <a:tc>
+                  <a:txBody>
+                    <a:bodyPr wrap="square"/>
+                    <a:lstStyle/>
+                    <a:p>
+                      <a:pPr algn="l"/>
+                      <a:r>
+                        <a:rPr sz="1300" b="1">
+                          <a:solidFill>
+                            <a:srgbClr val="1F1F1F"/>
+                          </a:solidFill>
+                          <a:latin typeface="Arial"/>
+                        </a:rPr>
+                        <a:t>Birge 比（raw）</a:t>
+                      </a:r>
+                    </a:p>
+                  </a:txBody>
+                  <a:tcPr anchor="ctr" marL="54864" marR="54864" marT="18288" marB="18288"/>
+                </a:tc>
+                <a:tc>
+                  <a:txBody>
+                    <a:bodyPr wrap="square"/>
+                    <a:lstStyle/>
+                    <a:p>
+                      <a:pPr algn="ctr"/>
+                      <a:r>
+                        <a:rPr sz="1300" b="0">
+                          <a:solidFill>
+                            <a:srgbClr val="1F1F1F"/>
+                          </a:solidFill>
+                          <a:latin typeface="Arial"/>
+                        </a:rPr>
+                        <a:t>2.329</a:t>
+                      </a:r>
+                    </a:p>
+                  </a:txBody>
+                  <a:tcPr anchor="ctr" marL="54864" marR="54864" marT="18288" marB="18288"/>
+                </a:tc>
+                <a:tc>
+                  <a:txBody>
+                    <a:bodyPr wrap="square"/>
+                    <a:lstStyle/>
+                    <a:p>
+                      <a:pPr algn="ctr"/>
+                      <a:r>
+                        <a:rPr sz="1300" b="0">
+                          <a:solidFill>
+                            <a:srgbClr val="1F1F1F"/>
+                          </a:solidFill>
+                          <a:latin typeface="Arial"/>
+                        </a:rPr>
+                        <a:t>1.638</a:t>
+                      </a:r>
+                    </a:p>
+                  </a:txBody>
+                  <a:tcPr anchor="ctr" marL="54864" marR="54864" marT="18288" marB="18288"/>
+                </a:tc>
+              </a:tr>
+              <a:tr h="365760">
+                <a:tc>
+                  <a:txBody>
+                    <a:bodyPr wrap="square"/>
+                    <a:lstStyle/>
+                    <a:p>
+                      <a:pPr algn="l"/>
+                      <a:r>
+                        <a:rPr sz="1300" b="1">
+                          <a:solidFill>
+                            <a:srgbClr val="1F1F1F"/>
+                          </a:solidFill>
+                          <a:latin typeface="Arial"/>
+                        </a:rPr>
+                        <a:t>贝叶斯统计 u（raw, ×10⁻¹⁸）</a:t>
+                      </a:r>
+                    </a:p>
+                  </a:txBody>
+                  <a:tcPr anchor="ctr" marL="54864" marR="54864" marT="18288" marB="18288"/>
+                </a:tc>
+                <a:tc>
+                  <a:txBody>
+                    <a:bodyPr wrap="square"/>
+                    <a:lstStyle/>
+                    <a:p>
+                      <a:pPr algn="ctr"/>
+                      <a:r>
+                        <a:rPr sz="1300" b="0">
+                          <a:solidFill>
+                            <a:srgbClr val="1F1F1F"/>
+                          </a:solidFill>
+                          <a:latin typeface="Arial"/>
+                        </a:rPr>
+                        <a:t>0.800</a:t>
+                      </a:r>
+                    </a:p>
+                  </a:txBody>
+                  <a:tcPr anchor="ctr" marL="54864" marR="54864" marT="18288" marB="18288"/>
+                </a:tc>
+                <a:tc>
+                  <a:txBody>
+                    <a:bodyPr wrap="square"/>
+                    <a:lstStyle/>
+                    <a:p>
+                      <a:pPr algn="ctr"/>
+                      <a:r>
+                        <a:rPr sz="1300" b="0">
+                          <a:solidFill>
+                            <a:srgbClr val="1F1F1F"/>
+                          </a:solidFill>
+                          <a:latin typeface="Arial"/>
+                        </a:rPr>
+                        <a:t>0.546</a:t>
+                      </a:r>
+                    </a:p>
+                  </a:txBody>
+                  <a:tcPr anchor="ctr" marL="54864" marR="54864" marT="18288" marB="18288"/>
+                </a:tc>
+              </a:tr>
+              <a:tr h="365760">
+                <a:tc>
+                  <a:txBody>
+                    <a:bodyPr wrap="square"/>
+                    <a:lstStyle/>
+                    <a:p>
+                      <a:pPr algn="l"/>
+                      <a:r>
+                        <a:rPr sz="1300" b="1">
+                          <a:solidFill>
+                            <a:srgbClr val="1F1F1F"/>
+                          </a:solidFill>
+                          <a:latin typeface="Arial"/>
+                        </a:rPr>
+                        <a:t>贝叶斯中心值偏差 vs 实验 WLS（raw, ×10⁻¹⁸）</a:t>
+                      </a:r>
+                    </a:p>
+                  </a:txBody>
+                  <a:tcPr anchor="ctr" marL="54864" marR="54864" marT="18288" marB="18288"/>
+                </a:tc>
+                <a:tc>
+                  <a:txBody>
+                    <a:bodyPr wrap="square"/>
+                    <a:lstStyle/>
+                    <a:p>
+                      <a:pPr algn="ctr"/>
+                      <a:r>
+                        <a:rPr sz="1300" b="0">
+                          <a:solidFill>
+                            <a:srgbClr val="1F1F1F"/>
+                          </a:solidFill>
+                          <a:latin typeface="Arial"/>
+                        </a:rPr>
+                        <a:t>−0.016</a:t>
+                      </a:r>
+                    </a:p>
+                  </a:txBody>
+                  <a:tcPr anchor="ctr" marL="54864" marR="54864" marT="18288" marB="18288"/>
+                </a:tc>
+                <a:tc>
+                  <a:txBody>
+                    <a:bodyPr wrap="square"/>
+                    <a:lstStyle/>
+                    <a:p>
+                      <a:pPr algn="ctr"/>
+                      <a:r>
+                        <a:rPr sz="1300" b="0">
+                          <a:solidFill>
+                            <a:srgbClr val="1F1F1F"/>
+                          </a:solidFill>
+                          <a:latin typeface="Arial"/>
+                        </a:rPr>
+                        <a:t>−0.928</a:t>
+                      </a:r>
+                    </a:p>
+                  </a:txBody>
+                  <a:tcPr anchor="ctr" marL="54864" marR="54864" marT="18288" marB="18288"/>
+                </a:tc>
+              </a:tr>
+            </a:tbl>
+          </a:graphicData>
+        </a:graphic>
+      </p:graphicFrame>
+      <p:sp>
+        <p:nvSpPr>
+          <p:cNvPr id="7" name="TextBox 6"/>
+          <p:cNvSpPr txBox="1"/>
+          <p:nvPr/>
+        </p:nvSpPr>
+        <p:spPr>
+          <a:xfrm>
+            <a:off x="731520" y="5394960"/>
+            <a:ext cx="10725912" cy="1234440"/>
+          </a:xfrm>
+          <a:prstGeom prst="rect">
+            <a:avLst/>
+          </a:prstGeom>
+          <a:noFill/>
+        </p:spPr>
+        <p:txBody>
+          <a:bodyPr wrap="square" anchor="t">
+            <a:spAutoFit/>
+          </a:bodyPr>
+          <a:lstStyle/>
+          <a:p>
+            <a:pPr algn="l">
+              <a:lnSpc>
+                <a:spcPct val="105000"/>
+              </a:lnSpc>
+            </a:pPr>
+            <a:r>
+              <a:rPr sz="1500" b="0">
+                <a:solidFill>
+                  <a:srgbClr val="1F1F1F"/>
+                </a:solidFill>
+                <a:latin typeface="Arial"/>
+              </a:rPr>
+              <a:t>• 去第 9 段后 χ²_red 由 5.42 降至 2.68、Birge 比由 2.33 降至 1.64，段间一致性明显改善</a:t>
+            </a:r>
+          </a:p>
+          <a:p>
+            <a:pPr algn="l">
+              <a:lnSpc>
+                <a:spcPct val="105000"/>
+              </a:lnSpc>
+            </a:pPr>
+            <a:r>
+              <a:rPr sz="1500" b="0">
+                <a:solidFill>
+                  <a:srgbClr val="1F1F1F"/>
+                </a:solidFill>
+                <a:latin typeface="Arial"/>
+              </a:rPr>
+              <a:t>• 但四法中心值整体下移约 −0.6～−0.9×10⁻¹⁸；且潮汐补偿使 χ²_red 改善的优势翻转：17 段 −31.8% → 16 段 +5.1%</a:t>
+            </a:r>
+          </a:p>
+          <a:p>
+            <a:pPr algn="l">
+              <a:lnSpc>
+                <a:spcPct val="105000"/>
+              </a:lnSpc>
+            </a:pPr>
+            <a:r>
+              <a:rPr sz="1500" b="1">
+                <a:solidFill>
+                  <a:srgbClr val="C0392B"/>
+                </a:solidFill>
+                <a:latin typeface="Arial"/>
+              </a:rPr>
+              <a:t>• 结论：主结果仍取 17 段；第 9 段对“潮汐补偿改善一致性”的结论影响显著，需在方法中说明</a:t>
+            </a:r>
+          </a:p>
+        </p:txBody>
+      </p:sp>
+      <p:sp>
+        <p:nvSpPr>
+          <p:cNvPr id="8" name="TextBox 7"/>
+          <p:cNvSpPr txBox="1"/>
+          <p:nvPr/>
+        </p:nvSpPr>
+        <p:spPr>
+          <a:xfrm>
+            <a:off x="731520" y="6492240"/>
+            <a:ext cx="10725912" cy="274320"/>
+          </a:xfrm>
+          <a:prstGeom prst="rect">
+            <a:avLst/>
+          </a:prstGeom>
+          <a:noFill/>
+        </p:spPr>
+        <p:txBody>
+          <a:bodyPr wrap="square" anchor="t">
+            <a:spAutoFit/>
+          </a:bodyPr>
+          <a:lstStyle/>
+          <a:p>
+            <a:pPr algn="l"/>
+            <a:r>
+              <a:rPr sz="1050" b="0">
+                <a:solidFill>
+                  <a:srgbClr val="606060"/>
+                </a:solidFill>
+                <a:latin typeface="Arial"/>
+              </a:rPr>
+              <a:t>来源：clock_ratio/statistical_methods_tidal_seg9_excluded.json；correlation_reanalysis_seg9_*.{csv,json}；docs/METHODOLOGY.md §8、§11</a:t>
             </a:r>
           </a:p>
         </p:txBody>
@@ -7724,6 +8185,164 @@
                 <a:latin typeface="Arial"/>
               </a:rPr>
               <a:t>来源：docs/raw/上研院…pptx；光钟比对论文 hj.docx；武汉-上海水准测量0930R1.docx</a:t>
+            </a:r>
+          </a:p>
+        </p:txBody>
+      </p:sp>
+    </p:spTree>
+  </p:cSld>
+  <p:clrMapOvr>
+    <a:masterClrMapping/>
+  </p:clrMapOvr>
+</p:sld>
+</file>
+
+<file path=ppt/slides/slide20.xml><?xml version="1.0" encoding="utf-8"?>
+<p:sld xmlns:a="http://schemas.openxmlformats.org/drawingml/2006/main" xmlns:p="http://schemas.openxmlformats.org/presentationml/2006/main" xmlns:r="http://schemas.openxmlformats.org/officeDocument/2006/relationships">
+  <p:cSld>
+    <p:spTree>
+      <p:nvGrpSpPr>
+        <p:cNvPr id="1" name=""/>
+        <p:cNvGrpSpPr/>
+        <p:nvPr/>
+      </p:nvGrpSpPr>
+      <p:grpSpPr/>
+      <p:sp>
+        <p:nvSpPr>
+          <p:cNvPr id="2" name="TextBox 1"/>
+          <p:cNvSpPr txBox="1"/>
+          <p:nvPr/>
+        </p:nvSpPr>
+        <p:spPr>
+          <a:xfrm>
+            <a:off x="640080" y="411480"/>
+            <a:ext cx="10911535" cy="822960"/>
+          </a:xfrm>
+          <a:prstGeom prst="rect">
+            <a:avLst/>
+          </a:prstGeom>
+          <a:noFill/>
+        </p:spPr>
+        <p:txBody>
+          <a:bodyPr wrap="square">
+            <a:spAutoFit/>
+          </a:bodyPr>
+          <a:lstStyle/>
+          <a:p>
+            <a:r>
+              <a:rPr sz="3000" b="1">
+                <a:solidFill>
+                  <a:srgbClr val="1F3A5F"/>
+                </a:solidFill>
+                <a:latin typeface="Arial"/>
+              </a:rPr>
+              <a:t>十六、问题（待补充）</a:t>
+            </a:r>
+          </a:p>
+        </p:txBody>
+      </p:sp>
+      <p:sp>
+        <p:nvSpPr>
+          <p:cNvPr id="3" name="TextBox 2"/>
+          <p:cNvSpPr txBox="1"/>
+          <p:nvPr/>
+        </p:nvSpPr>
+        <p:spPr>
+          <a:xfrm>
+            <a:off x="658368" y="1188720"/>
+            <a:ext cx="10911535" cy="54864"/>
+          </a:xfrm>
+          <a:prstGeom prst="rect">
+            <a:avLst/>
+          </a:prstGeom>
+          <a:solidFill>
+            <a:srgbClr val="2E6DA4"/>
+          </a:solidFill>
+          <a:ln>
+            <a:noFill/>
+          </a:ln>
+        </p:spPr>
+        <p:txBody>
+          <a:bodyPr wrap="none">
+            <a:spAutoFit/>
+          </a:bodyPr>
+          <a:lstStyle/>
+          <a:p/>
+        </p:txBody>
+      </p:sp>
+      <p:sp>
+        <p:nvSpPr>
+          <p:cNvPr id="4" name="TextBox 3"/>
+          <p:cNvSpPr txBox="1"/>
+          <p:nvPr/>
+        </p:nvSpPr>
+        <p:spPr>
+          <a:xfrm>
+            <a:off x="658368" y="1243584"/>
+            <a:ext cx="10911535" cy="457200"/>
+          </a:xfrm>
+          <a:prstGeom prst="rect">
+            <a:avLst/>
+          </a:prstGeom>
+          <a:noFill/>
+        </p:spPr>
+        <p:txBody>
+          <a:bodyPr wrap="square">
+            <a:spAutoFit/>
+          </a:bodyPr>
+          <a:lstStyle/>
+          <a:p>
+            <a:r>
+              <a:rPr sz="1400" b="0">
+                <a:solidFill>
+                  <a:srgbClr val="8A8A8A"/>
+                </a:solidFill>
+                <a:latin typeface="Arial"/>
+              </a:rPr>
+              <a:t>（留空，后续补充）</a:t>
+            </a:r>
+          </a:p>
+        </p:txBody>
+      </p:sp>
+      <p:sp>
+        <p:nvSpPr>
+          <p:cNvPr id="5" name="TextBox 4"/>
+          <p:cNvSpPr txBox="1"/>
+          <p:nvPr/>
+        </p:nvSpPr>
+        <p:spPr>
+          <a:xfrm>
+            <a:off x="822960" y="2103120"/>
+            <a:ext cx="10545775" cy="3200400"/>
+          </a:xfrm>
+          <a:prstGeom prst="rect">
+            <a:avLst/>
+          </a:prstGeom>
+          <a:solidFill>
+            <a:srgbClr val="F4F6F9"/>
+          </a:solidFill>
+          <a:ln>
+            <a:solidFill>
+              <a:srgbClr val="8A8A8A"/>
+            </a:solidFill>
+          </a:ln>
+        </p:spPr>
+        <p:txBody>
+          <a:bodyPr wrap="square">
+            <a:spAutoFit/>
+          </a:bodyPr>
+          <a:lstStyle/>
+          <a:p/>
+          <a:p/>
+          <a:p>
+            <a:r>
+              <a:rPr sz="1600" b="0">
+                <a:solidFill>
+                  <a:srgbClr val="8A8A8A"/>
+                </a:solidFill>
+                <a:latin typeface="Arial"/>
+              </a:rPr>
+              <a:t>（本页留空，用于补充待解决的问题）</a:t>
             </a:r>
           </a:p>
         </p:txBody>

</xml_diff>

<commit_message>
实验情况介绍.pptx: state explicit centre-value shift on segment-9 slide
- Add Delta column to the comparison table and a dedicated centre-value row
  (vs experiment WLS, raw): Bayesian -0.016 -> -0.928, i.e. -0.912e-18
- Takeaway now lists the centre shifts for all methods:
  Bayesian -0.912, Mandel-Paule -0.699, WLS -0.649 (1e-18)
</commit_message>
<xml_diff>
--- a/docs/实验情况介绍.pptx
+++ b/docs/实验情况介绍.pptx
@@ -7465,340 +7465,6 @@
           </a:p>
         </p:txBody>
       </p:sp>
-      <p:graphicFrame>
-        <p:nvGraphicFramePr>
-          <p:cNvPr id="6" name="Table 5"/>
-          <p:cNvGraphicFramePr>
-            <a:graphicFrameLocks noGrp="1"/>
-          </p:cNvGraphicFramePr>
-          <p:nvPr/>
-        </p:nvGraphicFramePr>
-        <p:xfrm>
-          <a:off x="822960" y="2788920"/>
-          <a:ext cx="10515600" cy="1847088"/>
-        </p:xfrm>
-        <a:graphic>
-          <a:graphicData uri="http://schemas.openxmlformats.org/drawingml/2006/table">
-            <a:tbl>
-              <a:tblPr firstRow="1" bandRow="1">
-                <a:tableStyleId>{5C22544A-7EE6-4342-B048-85BDC9FD1C3A}</a:tableStyleId>
-              </a:tblPr>
-              <a:tblGrid>
-                <a:gridCol w="4846320"/>
-                <a:gridCol w="2834640"/>
-                <a:gridCol w="2834640"/>
-              </a:tblGrid>
-              <a:tr h="384048">
-                <a:tc>
-                  <a:txBody>
-                    <a:bodyPr wrap="square"/>
-                    <a:lstStyle/>
-                    <a:p>
-                      <a:pPr algn="l"/>
-                      <a:r>
-                        <a:rPr sz="1400" b="1">
-                          <a:solidFill>
-                            <a:srgbClr val="FFFFFF"/>
-                          </a:solidFill>
-                          <a:latin typeface="Arial"/>
-                        </a:rPr>
-                        <a:t>指标</a:t>
-                      </a:r>
-                    </a:p>
-                  </a:txBody>
-                  <a:tcPr anchor="ctr" marL="54864" marR="54864" marT="18288" marB="18288">
-                    <a:solidFill>
-                      <a:srgbClr val="2E6DA4"/>
-                    </a:solidFill>
-                  </a:tcPr>
-                </a:tc>
-                <a:tc>
-                  <a:txBody>
-                    <a:bodyPr wrap="square"/>
-                    <a:lstStyle/>
-                    <a:p>
-                      <a:pPr algn="ctr"/>
-                      <a:r>
-                        <a:rPr sz="1400" b="1">
-                          <a:solidFill>
-                            <a:srgbClr val="FFFFFF"/>
-                          </a:solidFill>
-                          <a:latin typeface="Arial"/>
-                        </a:rPr>
-                        <a:t>17 段（主结果）</a:t>
-                      </a:r>
-                    </a:p>
-                  </a:txBody>
-                  <a:tcPr anchor="ctr" marL="54864" marR="54864" marT="18288" marB="18288">
-                    <a:solidFill>
-                      <a:srgbClr val="2E6DA4"/>
-                    </a:solidFill>
-                  </a:tcPr>
-                </a:tc>
-                <a:tc>
-                  <a:txBody>
-                    <a:bodyPr wrap="square"/>
-                    <a:lstStyle/>
-                    <a:p>
-                      <a:pPr algn="ctr"/>
-                      <a:r>
-                        <a:rPr sz="1400" b="1">
-                          <a:solidFill>
-                            <a:srgbClr val="FFFFFF"/>
-                          </a:solidFill>
-                          <a:latin typeface="Arial"/>
-                        </a:rPr>
-                        <a:t>16 段（去第 9 段）</a:t>
-                      </a:r>
-                    </a:p>
-                  </a:txBody>
-                  <a:tcPr anchor="ctr" marL="54864" marR="54864" marT="18288" marB="18288">
-                    <a:solidFill>
-                      <a:srgbClr val="2E6DA4"/>
-                    </a:solidFill>
-                  </a:tcPr>
-                </a:tc>
-              </a:tr>
-              <a:tr h="365760">
-                <a:tc>
-                  <a:txBody>
-                    <a:bodyPr wrap="square"/>
-                    <a:lstStyle/>
-                    <a:p>
-                      <a:pPr algn="l"/>
-                      <a:r>
-                        <a:rPr sz="1300" b="1">
-                          <a:solidFill>
-                            <a:srgbClr val="1F1F1F"/>
-                          </a:solidFill>
-                          <a:latin typeface="Arial"/>
-                        </a:rPr>
-                        <a:t>χ²_red（raw）</a:t>
-                      </a:r>
-                    </a:p>
-                  </a:txBody>
-                  <a:tcPr anchor="ctr" marL="54864" marR="54864" marT="18288" marB="18288"/>
-                </a:tc>
-                <a:tc>
-                  <a:txBody>
-                    <a:bodyPr wrap="square"/>
-                    <a:lstStyle/>
-                    <a:p>
-                      <a:pPr algn="ctr"/>
-                      <a:r>
-                        <a:rPr sz="1300" b="0">
-                          <a:solidFill>
-                            <a:srgbClr val="1F1F1F"/>
-                          </a:solidFill>
-                          <a:latin typeface="Arial"/>
-                        </a:rPr>
-                        <a:t>5.424</a:t>
-                      </a:r>
-                    </a:p>
-                  </a:txBody>
-                  <a:tcPr anchor="ctr" marL="54864" marR="54864" marT="18288" marB="18288"/>
-                </a:tc>
-                <a:tc>
-                  <a:txBody>
-                    <a:bodyPr wrap="square"/>
-                    <a:lstStyle/>
-                    <a:p>
-                      <a:pPr algn="ctr"/>
-                      <a:r>
-                        <a:rPr sz="1300" b="0">
-                          <a:solidFill>
-                            <a:srgbClr val="1F1F1F"/>
-                          </a:solidFill>
-                          <a:latin typeface="Arial"/>
-                        </a:rPr>
-                        <a:t>2.684</a:t>
-                      </a:r>
-                    </a:p>
-                  </a:txBody>
-                  <a:tcPr anchor="ctr" marL="54864" marR="54864" marT="18288" marB="18288"/>
-                </a:tc>
-              </a:tr>
-              <a:tr h="365760">
-                <a:tc>
-                  <a:txBody>
-                    <a:bodyPr wrap="square"/>
-                    <a:lstStyle/>
-                    <a:p>
-                      <a:pPr algn="l"/>
-                      <a:r>
-                        <a:rPr sz="1300" b="1">
-                          <a:solidFill>
-                            <a:srgbClr val="1F1F1F"/>
-                          </a:solidFill>
-                          <a:latin typeface="Arial"/>
-                        </a:rPr>
-                        <a:t>Birge 比（raw）</a:t>
-                      </a:r>
-                    </a:p>
-                  </a:txBody>
-                  <a:tcPr anchor="ctr" marL="54864" marR="54864" marT="18288" marB="18288"/>
-                </a:tc>
-                <a:tc>
-                  <a:txBody>
-                    <a:bodyPr wrap="square"/>
-                    <a:lstStyle/>
-                    <a:p>
-                      <a:pPr algn="ctr"/>
-                      <a:r>
-                        <a:rPr sz="1300" b="0">
-                          <a:solidFill>
-                            <a:srgbClr val="1F1F1F"/>
-                          </a:solidFill>
-                          <a:latin typeface="Arial"/>
-                        </a:rPr>
-                        <a:t>2.329</a:t>
-                      </a:r>
-                    </a:p>
-                  </a:txBody>
-                  <a:tcPr anchor="ctr" marL="54864" marR="54864" marT="18288" marB="18288"/>
-                </a:tc>
-                <a:tc>
-                  <a:txBody>
-                    <a:bodyPr wrap="square"/>
-                    <a:lstStyle/>
-                    <a:p>
-                      <a:pPr algn="ctr"/>
-                      <a:r>
-                        <a:rPr sz="1300" b="0">
-                          <a:solidFill>
-                            <a:srgbClr val="1F1F1F"/>
-                          </a:solidFill>
-                          <a:latin typeface="Arial"/>
-                        </a:rPr>
-                        <a:t>1.638</a:t>
-                      </a:r>
-                    </a:p>
-                  </a:txBody>
-                  <a:tcPr anchor="ctr" marL="54864" marR="54864" marT="18288" marB="18288"/>
-                </a:tc>
-              </a:tr>
-              <a:tr h="365760">
-                <a:tc>
-                  <a:txBody>
-                    <a:bodyPr wrap="square"/>
-                    <a:lstStyle/>
-                    <a:p>
-                      <a:pPr algn="l"/>
-                      <a:r>
-                        <a:rPr sz="1300" b="1">
-                          <a:solidFill>
-                            <a:srgbClr val="1F1F1F"/>
-                          </a:solidFill>
-                          <a:latin typeface="Arial"/>
-                        </a:rPr>
-                        <a:t>贝叶斯统计 u（raw, ×10⁻¹⁸）</a:t>
-                      </a:r>
-                    </a:p>
-                  </a:txBody>
-                  <a:tcPr anchor="ctr" marL="54864" marR="54864" marT="18288" marB="18288"/>
-                </a:tc>
-                <a:tc>
-                  <a:txBody>
-                    <a:bodyPr wrap="square"/>
-                    <a:lstStyle/>
-                    <a:p>
-                      <a:pPr algn="ctr"/>
-                      <a:r>
-                        <a:rPr sz="1300" b="0">
-                          <a:solidFill>
-                            <a:srgbClr val="1F1F1F"/>
-                          </a:solidFill>
-                          <a:latin typeface="Arial"/>
-                        </a:rPr>
-                        <a:t>0.800</a:t>
-                      </a:r>
-                    </a:p>
-                  </a:txBody>
-                  <a:tcPr anchor="ctr" marL="54864" marR="54864" marT="18288" marB="18288"/>
-                </a:tc>
-                <a:tc>
-                  <a:txBody>
-                    <a:bodyPr wrap="square"/>
-                    <a:lstStyle/>
-                    <a:p>
-                      <a:pPr algn="ctr"/>
-                      <a:r>
-                        <a:rPr sz="1300" b="0">
-                          <a:solidFill>
-                            <a:srgbClr val="1F1F1F"/>
-                          </a:solidFill>
-                          <a:latin typeface="Arial"/>
-                        </a:rPr>
-                        <a:t>0.546</a:t>
-                      </a:r>
-                    </a:p>
-                  </a:txBody>
-                  <a:tcPr anchor="ctr" marL="54864" marR="54864" marT="18288" marB="18288"/>
-                </a:tc>
-              </a:tr>
-              <a:tr h="365760">
-                <a:tc>
-                  <a:txBody>
-                    <a:bodyPr wrap="square"/>
-                    <a:lstStyle/>
-                    <a:p>
-                      <a:pPr algn="l"/>
-                      <a:r>
-                        <a:rPr sz="1300" b="1">
-                          <a:solidFill>
-                            <a:srgbClr val="1F1F1F"/>
-                          </a:solidFill>
-                          <a:latin typeface="Arial"/>
-                        </a:rPr>
-                        <a:t>贝叶斯中心值偏差 vs 实验 WLS（raw, ×10⁻¹⁸）</a:t>
-                      </a:r>
-                    </a:p>
-                  </a:txBody>
-                  <a:tcPr anchor="ctr" marL="54864" marR="54864" marT="18288" marB="18288"/>
-                </a:tc>
-                <a:tc>
-                  <a:txBody>
-                    <a:bodyPr wrap="square"/>
-                    <a:lstStyle/>
-                    <a:p>
-                      <a:pPr algn="ctr"/>
-                      <a:r>
-                        <a:rPr sz="1300" b="0">
-                          <a:solidFill>
-                            <a:srgbClr val="1F1F1F"/>
-                          </a:solidFill>
-                          <a:latin typeface="Arial"/>
-                        </a:rPr>
-                        <a:t>−0.016</a:t>
-                      </a:r>
-                    </a:p>
-                  </a:txBody>
-                  <a:tcPr anchor="ctr" marL="54864" marR="54864" marT="18288" marB="18288"/>
-                </a:tc>
-                <a:tc>
-                  <a:txBody>
-                    <a:bodyPr wrap="square"/>
-                    <a:lstStyle/>
-                    <a:p>
-                      <a:pPr algn="ctr"/>
-                      <a:r>
-                        <a:rPr sz="1300" b="0">
-                          <a:solidFill>
-                            <a:srgbClr val="1F1F1F"/>
-                          </a:solidFill>
-                          <a:latin typeface="Arial"/>
-                        </a:rPr>
-                        <a:t>−0.928</a:t>
-                      </a:r>
-                    </a:p>
-                  </a:txBody>
-                  <a:tcPr anchor="ctr" marL="54864" marR="54864" marT="18288" marB="18288"/>
-                </a:tc>
-              </a:tr>
-            </a:tbl>
-          </a:graphicData>
-        </a:graphic>
-      </p:graphicFrame>
       <p:sp>
         <p:nvSpPr>
           <p:cNvPr id="7" name="TextBox 6"/>
@@ -7849,7 +7515,7 @@
                 </a:solidFill>
                 <a:latin typeface="Arial"/>
               </a:rPr>
-              <a:t>• 但四法中心值整体下移约 −0.6～−0.9×10⁻¹⁸；且潮汐补偿使 χ²_red 改善的优势翻转：17 段 −31.8% → 16 段 +5.1%</a:t>
+              <a:t>• 中心值下移：贝叶斯 −0.912、Mandel–Paule −0.699、WLS −0.649（×10⁻¹⁸）；且潮汐补偿使 χ²_red 改善的优势翻转：17 段 −31.8% → 16 段 +5.1%</a:t>
             </a:r>
           </a:p>
           <a:p>
@@ -7905,6 +7571,440 @@
           </a:p>
         </p:txBody>
       </p:sp>
+      <p:graphicFrame>
+        <p:nvGraphicFramePr>
+          <p:cNvPr id="9" name="Table 8"/>
+          <p:cNvGraphicFramePr>
+            <a:graphicFrameLocks noGrp="1"/>
+          </p:cNvGraphicFramePr>
+          <p:nvPr/>
+        </p:nvGraphicFramePr>
+        <p:xfrm>
+          <a:off x="822960" y="2788920"/>
+          <a:ext cx="10515600" cy="2011680"/>
+        </p:xfrm>
+        <a:graphic>
+          <a:graphicData uri="http://schemas.openxmlformats.org/drawingml/2006/table">
+            <a:tbl>
+              <a:tblPr firstRow="1" bandRow="1">
+                <a:tableStyleId>{5C22544A-7EE6-4342-B048-85BDC9FD1C3A}</a:tableStyleId>
+              </a:tblPr>
+              <a:tblGrid>
+                <a:gridCol w="3931920"/>
+                <a:gridCol w="2194560"/>
+                <a:gridCol w="2194560"/>
+                <a:gridCol w="2194560"/>
+              </a:tblGrid>
+              <a:tr h="402336">
+                <a:tc>
+                  <a:txBody>
+                    <a:bodyPr wrap="square"/>
+                    <a:lstStyle/>
+                    <a:p>
+                      <a:pPr algn="l"/>
+                      <a:r>
+                        <a:rPr sz="1300" b="1">
+                          <a:solidFill>
+                            <a:srgbClr val="FFFFFF"/>
+                          </a:solidFill>
+                          <a:latin typeface="Arial"/>
+                        </a:rPr>
+                        <a:t>指标</a:t>
+                      </a:r>
+                    </a:p>
+                  </a:txBody>
+                  <a:tcPr anchor="ctr" marL="45720" marR="45720" marT="9144" marB="9144">
+                    <a:solidFill>
+                      <a:srgbClr val="2E6DA4"/>
+                    </a:solidFill>
+                  </a:tcPr>
+                </a:tc>
+                <a:tc>
+                  <a:txBody>
+                    <a:bodyPr wrap="square"/>
+                    <a:lstStyle/>
+                    <a:p>
+                      <a:pPr algn="ctr"/>
+                      <a:r>
+                        <a:rPr sz="1300" b="1">
+                          <a:solidFill>
+                            <a:srgbClr val="FFFFFF"/>
+                          </a:solidFill>
+                          <a:latin typeface="Arial"/>
+                        </a:rPr>
+                        <a:t>17 段（主结果）</a:t>
+                      </a:r>
+                    </a:p>
+                  </a:txBody>
+                  <a:tcPr anchor="ctr" marL="45720" marR="45720" marT="9144" marB="9144">
+                    <a:solidFill>
+                      <a:srgbClr val="2E6DA4"/>
+                    </a:solidFill>
+                  </a:tcPr>
+                </a:tc>
+                <a:tc>
+                  <a:txBody>
+                    <a:bodyPr wrap="square"/>
+                    <a:lstStyle/>
+                    <a:p>
+                      <a:pPr algn="ctr"/>
+                      <a:r>
+                        <a:rPr sz="1300" b="1">
+                          <a:solidFill>
+                            <a:srgbClr val="FFFFFF"/>
+                          </a:solidFill>
+                          <a:latin typeface="Arial"/>
+                        </a:rPr>
+                        <a:t>16 段（去第 9 段）</a:t>
+                      </a:r>
+                    </a:p>
+                  </a:txBody>
+                  <a:tcPr anchor="ctr" marL="45720" marR="45720" marT="9144" marB="9144">
+                    <a:solidFill>
+                      <a:srgbClr val="2E6DA4"/>
+                    </a:solidFill>
+                  </a:tcPr>
+                </a:tc>
+                <a:tc>
+                  <a:txBody>
+                    <a:bodyPr wrap="square"/>
+                    <a:lstStyle/>
+                    <a:p>
+                      <a:pPr algn="ctr"/>
+                      <a:r>
+                        <a:rPr sz="1300" b="1">
+                          <a:solidFill>
+                            <a:srgbClr val="FFFFFF"/>
+                          </a:solidFill>
+                          <a:latin typeface="Arial"/>
+                        </a:rPr>
+                        <a:t>Δ（16−17）</a:t>
+                      </a:r>
+                    </a:p>
+                  </a:txBody>
+                  <a:tcPr anchor="ctr" marL="45720" marR="45720" marT="9144" marB="9144">
+                    <a:solidFill>
+                      <a:srgbClr val="2E6DA4"/>
+                    </a:solidFill>
+                  </a:tcPr>
+                </a:tc>
+              </a:tr>
+              <a:tr h="402336">
+                <a:tc>
+                  <a:txBody>
+                    <a:bodyPr wrap="square"/>
+                    <a:lstStyle/>
+                    <a:p>
+                      <a:pPr algn="l"/>
+                      <a:r>
+                        <a:rPr sz="1300" b="1">
+                          <a:solidFill>
+                            <a:srgbClr val="1F1F1F"/>
+                          </a:solidFill>
+                          <a:latin typeface="Arial"/>
+                        </a:rPr>
+                        <a:t>χ²_red（raw）</a:t>
+                      </a:r>
+                    </a:p>
+                  </a:txBody>
+                  <a:tcPr anchor="ctr" marL="45720" marR="45720" marT="9144" marB="9144"/>
+                </a:tc>
+                <a:tc>
+                  <a:txBody>
+                    <a:bodyPr wrap="square"/>
+                    <a:lstStyle/>
+                    <a:p>
+                      <a:pPr algn="ctr"/>
+                      <a:r>
+                        <a:rPr sz="1300" b="0">
+                          <a:solidFill>
+                            <a:srgbClr val="1F1F1F"/>
+                          </a:solidFill>
+                          <a:latin typeface="Arial"/>
+                        </a:rPr>
+                        <a:t>5.424</a:t>
+                      </a:r>
+                    </a:p>
+                  </a:txBody>
+                  <a:tcPr anchor="ctr" marL="45720" marR="45720" marT="9144" marB="9144"/>
+                </a:tc>
+                <a:tc>
+                  <a:txBody>
+                    <a:bodyPr wrap="square"/>
+                    <a:lstStyle/>
+                    <a:p>
+                      <a:pPr algn="ctr"/>
+                      <a:r>
+                        <a:rPr sz="1300" b="0">
+                          <a:solidFill>
+                            <a:srgbClr val="1F1F1F"/>
+                          </a:solidFill>
+                          <a:latin typeface="Arial"/>
+                        </a:rPr>
+                        <a:t>2.684</a:t>
+                      </a:r>
+                    </a:p>
+                  </a:txBody>
+                  <a:tcPr anchor="ctr" marL="45720" marR="45720" marT="9144" marB="9144"/>
+                </a:tc>
+                <a:tc>
+                  <a:txBody>
+                    <a:bodyPr wrap="square"/>
+                    <a:lstStyle/>
+                    <a:p>
+                      <a:pPr algn="ctr"/>
+                      <a:r>
+                        <a:rPr sz="1300" b="0">
+                          <a:solidFill>
+                            <a:srgbClr val="1F1F1F"/>
+                          </a:solidFill>
+                          <a:latin typeface="Arial"/>
+                        </a:rPr>
+                        <a:t>−2.740</a:t>
+                      </a:r>
+                    </a:p>
+                  </a:txBody>
+                  <a:tcPr anchor="ctr" marL="45720" marR="45720" marT="9144" marB="9144"/>
+                </a:tc>
+              </a:tr>
+              <a:tr h="402336">
+                <a:tc>
+                  <a:txBody>
+                    <a:bodyPr wrap="square"/>
+                    <a:lstStyle/>
+                    <a:p>
+                      <a:pPr algn="l"/>
+                      <a:r>
+                        <a:rPr sz="1300" b="1">
+                          <a:solidFill>
+                            <a:srgbClr val="1F1F1F"/>
+                          </a:solidFill>
+                          <a:latin typeface="Arial"/>
+                        </a:rPr>
+                        <a:t>Birge 比（raw）</a:t>
+                      </a:r>
+                    </a:p>
+                  </a:txBody>
+                  <a:tcPr anchor="ctr" marL="45720" marR="45720" marT="9144" marB="9144"/>
+                </a:tc>
+                <a:tc>
+                  <a:txBody>
+                    <a:bodyPr wrap="square"/>
+                    <a:lstStyle/>
+                    <a:p>
+                      <a:pPr algn="ctr"/>
+                      <a:r>
+                        <a:rPr sz="1300" b="0">
+                          <a:solidFill>
+                            <a:srgbClr val="1F1F1F"/>
+                          </a:solidFill>
+                          <a:latin typeface="Arial"/>
+                        </a:rPr>
+                        <a:t>2.329</a:t>
+                      </a:r>
+                    </a:p>
+                  </a:txBody>
+                  <a:tcPr anchor="ctr" marL="45720" marR="45720" marT="9144" marB="9144"/>
+                </a:tc>
+                <a:tc>
+                  <a:txBody>
+                    <a:bodyPr wrap="square"/>
+                    <a:lstStyle/>
+                    <a:p>
+                      <a:pPr algn="ctr"/>
+                      <a:r>
+                        <a:rPr sz="1300" b="0">
+                          <a:solidFill>
+                            <a:srgbClr val="1F1F1F"/>
+                          </a:solidFill>
+                          <a:latin typeface="Arial"/>
+                        </a:rPr>
+                        <a:t>1.638</a:t>
+                      </a:r>
+                    </a:p>
+                  </a:txBody>
+                  <a:tcPr anchor="ctr" marL="45720" marR="45720" marT="9144" marB="9144"/>
+                </a:tc>
+                <a:tc>
+                  <a:txBody>
+                    <a:bodyPr wrap="square"/>
+                    <a:lstStyle/>
+                    <a:p>
+                      <a:pPr algn="ctr"/>
+                      <a:r>
+                        <a:rPr sz="1300" b="0">
+                          <a:solidFill>
+                            <a:srgbClr val="1F1F1F"/>
+                          </a:solidFill>
+                          <a:latin typeface="Arial"/>
+                        </a:rPr>
+                        <a:t>−0.691</a:t>
+                      </a:r>
+                    </a:p>
+                  </a:txBody>
+                  <a:tcPr anchor="ctr" marL="45720" marR="45720" marT="9144" marB="9144"/>
+                </a:tc>
+              </a:tr>
+              <a:tr h="402336">
+                <a:tc>
+                  <a:txBody>
+                    <a:bodyPr wrap="square"/>
+                    <a:lstStyle/>
+                    <a:p>
+                      <a:pPr algn="l"/>
+                      <a:r>
+                        <a:rPr sz="1300" b="1">
+                          <a:solidFill>
+                            <a:srgbClr val="1F1F1F"/>
+                          </a:solidFill>
+                          <a:latin typeface="Arial"/>
+                        </a:rPr>
+                        <a:t>贝叶斯统计 u（raw, ×10⁻¹⁸）</a:t>
+                      </a:r>
+                    </a:p>
+                  </a:txBody>
+                  <a:tcPr anchor="ctr" marL="45720" marR="45720" marT="9144" marB="9144"/>
+                </a:tc>
+                <a:tc>
+                  <a:txBody>
+                    <a:bodyPr wrap="square"/>
+                    <a:lstStyle/>
+                    <a:p>
+                      <a:pPr algn="ctr"/>
+                      <a:r>
+                        <a:rPr sz="1300" b="0">
+                          <a:solidFill>
+                            <a:srgbClr val="1F1F1F"/>
+                          </a:solidFill>
+                          <a:latin typeface="Arial"/>
+                        </a:rPr>
+                        <a:t>0.800</a:t>
+                      </a:r>
+                    </a:p>
+                  </a:txBody>
+                  <a:tcPr anchor="ctr" marL="45720" marR="45720" marT="9144" marB="9144"/>
+                </a:tc>
+                <a:tc>
+                  <a:txBody>
+                    <a:bodyPr wrap="square"/>
+                    <a:lstStyle/>
+                    <a:p>
+                      <a:pPr algn="ctr"/>
+                      <a:r>
+                        <a:rPr sz="1300" b="0">
+                          <a:solidFill>
+                            <a:srgbClr val="1F1F1F"/>
+                          </a:solidFill>
+                          <a:latin typeface="Arial"/>
+                        </a:rPr>
+                        <a:t>0.546</a:t>
+                      </a:r>
+                    </a:p>
+                  </a:txBody>
+                  <a:tcPr anchor="ctr" marL="45720" marR="45720" marT="9144" marB="9144"/>
+                </a:tc>
+                <a:tc>
+                  <a:txBody>
+                    <a:bodyPr wrap="square"/>
+                    <a:lstStyle/>
+                    <a:p>
+                      <a:pPr algn="ctr"/>
+                      <a:r>
+                        <a:rPr sz="1300" b="0">
+                          <a:solidFill>
+                            <a:srgbClr val="1F1F1F"/>
+                          </a:solidFill>
+                          <a:latin typeface="Arial"/>
+                        </a:rPr>
+                        <a:t>−0.254</a:t>
+                      </a:r>
+                    </a:p>
+                  </a:txBody>
+                  <a:tcPr anchor="ctr" marL="45720" marR="45720" marT="9144" marB="9144"/>
+                </a:tc>
+              </a:tr>
+              <a:tr h="402336">
+                <a:tc>
+                  <a:txBody>
+                    <a:bodyPr wrap="square"/>
+                    <a:lstStyle/>
+                    <a:p>
+                      <a:pPr algn="l"/>
+                      <a:r>
+                        <a:rPr sz="1300" b="1">
+                          <a:solidFill>
+                            <a:srgbClr val="1F1F1F"/>
+                          </a:solidFill>
+                          <a:latin typeface="Arial"/>
+                        </a:rPr>
+                        <a:t>中心值 vs 实验 WLS（raw, ×10⁻¹⁸）</a:t>
+                      </a:r>
+                    </a:p>
+                  </a:txBody>
+                  <a:tcPr anchor="ctr" marL="45720" marR="45720" marT="9144" marB="9144"/>
+                </a:tc>
+                <a:tc>
+                  <a:txBody>
+                    <a:bodyPr wrap="square"/>
+                    <a:lstStyle/>
+                    <a:p>
+                      <a:pPr algn="ctr"/>
+                      <a:r>
+                        <a:rPr sz="1300" b="1">
+                          <a:solidFill>
+                            <a:srgbClr val="1F1F1F"/>
+                          </a:solidFill>
+                          <a:latin typeface="Arial"/>
+                        </a:rPr>
+                        <a:t>−0.016</a:t>
+                      </a:r>
+                    </a:p>
+                  </a:txBody>
+                  <a:tcPr anchor="ctr" marL="45720" marR="45720" marT="9144" marB="9144"/>
+                </a:tc>
+                <a:tc>
+                  <a:txBody>
+                    <a:bodyPr wrap="square"/>
+                    <a:lstStyle/>
+                    <a:p>
+                      <a:pPr algn="ctr"/>
+                      <a:r>
+                        <a:rPr sz="1300" b="1">
+                          <a:solidFill>
+                            <a:srgbClr val="1F1F1F"/>
+                          </a:solidFill>
+                          <a:latin typeface="Arial"/>
+                        </a:rPr>
+                        <a:t>−0.928</a:t>
+                      </a:r>
+                    </a:p>
+                  </a:txBody>
+                  <a:tcPr anchor="ctr" marL="45720" marR="45720" marT="9144" marB="9144"/>
+                </a:tc>
+                <a:tc>
+                  <a:txBody>
+                    <a:bodyPr wrap="square"/>
+                    <a:lstStyle/>
+                    <a:p>
+                      <a:pPr algn="ctr"/>
+                      <a:r>
+                        <a:rPr sz="1300" b="1">
+                          <a:solidFill>
+                            <a:srgbClr val="C0392B"/>
+                          </a:solidFill>
+                          <a:latin typeface="Arial"/>
+                        </a:rPr>
+                        <a:t>−0.912</a:t>
+                      </a:r>
+                    </a:p>
+                  </a:txBody>
+                  <a:tcPr anchor="ctr" marL="45720" marR="45720" marT="9144" marB="9144"/>
+                </a:tc>
+              </a:tr>
+            </a:tbl>
+          </a:graphicData>
+        </a:graphic>
+      </p:graphicFrame>
     </p:spTree>
   </p:cSld>
   <p:clrMapOvr>

</xml_diff>

<commit_message>
实验情况介绍.pptx: foreground Bayesian result on segment-9 slide
- Highlight box states the primary result (Bayesian random-effect, raw):
  17 seg 1.207 507 039 343 337 7213(8), u=0.800e-18
  16 seg 1.207 507 039 343 337 7204(5), u=0.546e-18
  centre shift dR = -0.912e-18
- Correct centre digits (7212/7203 -> 7213/7204) to match source 19-dp values
- Support table now diagnostic: chi2_red, Birge, Bayesian xi (2.614->0.980)
- Takeaway leads with the Bayesian centre; existing slides unchanged
</commit_message>
<xml_diff>
--- a/docs/实验情况介绍.pptx
+++ b/docs/实验情况介绍.pptx
@@ -7473,7 +7473,7 @@
         </p:nvSpPr>
         <p:spPr>
           <a:xfrm>
-            <a:off x="731520" y="5394960"/>
+            <a:off x="731520" y="6053328"/>
             <a:ext cx="10725912" cy="1234440"/>
           </a:xfrm>
           <a:prstGeom prst="rect">
@@ -7487,9 +7487,9 @@
           </a:bodyPr>
           <a:lstStyle/>
           <a:p>
-            <a:pPr algn="l">
+            <a:pPr>
               <a:lnSpc>
-                <a:spcPct val="105000"/>
+                <a:spcPct val="100000"/>
               </a:lnSpc>
             </a:pPr>
             <a:r>
@@ -7499,29 +7499,29 @@
                 </a:solidFill>
                 <a:latin typeface="Arial"/>
               </a:rPr>
-              <a:t>• 去第 9 段后 χ²_red 由 5.42 降至 2.68、Birge 比由 2.33 降至 1.64，段间一致性明显改善</a:t>
-            </a:r>
-          </a:p>
-          <a:p>
-            <a:pPr algn="l">
+              <a:t>• 主结果取 17 段贝叶斯中心值 1.207 507 039 343 337 7213(8)；去第 9 段后下移 −0.912×10⁻¹⁸</a:t>
+            </a:r>
+          </a:p>
+          <a:p>
+            <a:pPr>
               <a:lnSpc>
-                <a:spcPct val="105000"/>
+                <a:spcPct val="100000"/>
               </a:lnSpc>
             </a:pPr>
             <a:r>
-              <a:rPr sz="1500" b="0">
+              <a:rPr sz="1350" b="0">
                 <a:solidFill>
                   <a:srgbClr val="1F1F1F"/>
                 </a:solidFill>
                 <a:latin typeface="Arial"/>
               </a:rPr>
-              <a:t>• 中心值下移：贝叶斯 −0.912、Mandel–Paule −0.699、WLS −0.649（×10⁻¹⁸）；且潮汐补偿使 χ²_red 改善的优势翻转：17 段 −31.8% → 16 段 +5.1%</a:t>
-            </a:r>
-          </a:p>
-          <a:p>
-            <a:pPr algn="l">
+              <a:t>• 段间一致性改善（χ²_red 5.42→2.68、Birge 2.33→1.64）；潮汐补偿的 χ²_red 改善优势翻转：17 段 −31.8% → 16 段 +5.1%</a:t>
+            </a:r>
+          </a:p>
+          <a:p>
+            <a:pPr>
               <a:lnSpc>
-                <a:spcPct val="105000"/>
+                <a:spcPct val="100000"/>
               </a:lnSpc>
             </a:pPr>
             <a:r>
@@ -7531,7 +7531,7 @@
                 </a:solidFill>
                 <a:latin typeface="Arial"/>
               </a:rPr>
-              <a:t>• 结论：主结果仍取 17 段；第 9 段对“潮汐补偿改善一致性”的结论影响显著，需在方法中说明</a:t>
+              <a:t>• 结论：第 9 段对“潮汐补偿改善一致性”的结论影响显著；主结果不变，需在方法中说明</a:t>
             </a:r>
           </a:p>
         </p:txBody>
@@ -7544,7 +7544,7 @@
         </p:nvSpPr>
         <p:spPr>
           <a:xfrm>
-            <a:off x="731520" y="6492240"/>
+            <a:off x="731520" y="6446520"/>
             <a:ext cx="10725912" cy="274320"/>
           </a:xfrm>
           <a:prstGeom prst="rect">
@@ -7571,17 +7571,105 @@
           </a:p>
         </p:txBody>
       </p:sp>
+      <p:sp>
+        <p:nvSpPr>
+          <p:cNvPr id="9" name="Rounded Rectangle 8"/>
+          <p:cNvSpPr/>
+          <p:nvPr/>
+        </p:nvSpPr>
+        <p:spPr>
+          <a:xfrm>
+            <a:off x="731520" y="2697480"/>
+            <a:ext cx="10698480" cy="1280160"/>
+          </a:xfrm>
+          <a:prstGeom prst="roundRect">
+            <a:avLst/>
+          </a:prstGeom>
+          <a:solidFill>
+            <a:srgbClr val="EAF2FA"/>
+          </a:solidFill>
+          <a:ln>
+            <a:solidFill>
+              <a:srgbClr val="EAF2FA"/>
+            </a:solidFill>
+          </a:ln>
+          <a:effectLst/>
+        </p:spPr>
+        <p:style>
+          <a:lnRef idx="1">
+            <a:schemeClr val="accent1"/>
+          </a:lnRef>
+          <a:fillRef idx="3">
+            <a:schemeClr val="accent1"/>
+          </a:fillRef>
+          <a:effectRef idx="2">
+            <a:schemeClr val="accent1"/>
+          </a:effectRef>
+          <a:fontRef idx="minor">
+            <a:schemeClr val="lt1"/>
+          </a:fontRef>
+        </p:style>
+        <p:txBody>
+          <a:bodyPr rtlCol="0" anchor="ctr" wrap="square"/>
+          <a:lstStyle/>
+          <a:p>
+            <a:pPr algn="ctr"/>
+            <a:r>
+              <a:rPr sz="1500" b="1">
+                <a:solidFill>
+                  <a:srgbClr val="2E6DA4"/>
+                </a:solidFill>
+                <a:latin typeface="Arial"/>
+              </a:rPr>
+              <a:t>主结果（贝叶斯随机效应模型，raw 未修正）：</a:t>
+            </a:r>
+          </a:p>
+          <a:p>
+            <a:r>
+              <a:rPr sz="1500" b="1">
+                <a:solidFill>
+                  <a:srgbClr val="1F1F1F"/>
+                </a:solidFill>
+                <a:latin typeface="Arial"/>
+              </a:rPr>
+              <a:t>17 段    Yb/Sr = 1.207 507 039 343 337 7213(8)   ·   统计 u = 0.800×10⁻¹⁸</a:t>
+            </a:r>
+          </a:p>
+          <a:p>
+            <a:r>
+              <a:rPr sz="1500" b="1">
+                <a:solidFill>
+                  <a:srgbClr val="1F1F1F"/>
+                </a:solidFill>
+                <a:latin typeface="Arial"/>
+              </a:rPr>
+              <a:t>16 段（去第 9 段）   1.207 507 039 343 337 7204(5)   ·   统计 u = 0.546×10⁻¹⁸</a:t>
+            </a:r>
+          </a:p>
+          <a:p>
+            <a:r>
+              <a:rPr sz="1500" b="1">
+                <a:solidFill>
+                  <a:srgbClr val="C0392B"/>
+                </a:solidFill>
+                <a:latin typeface="Arial"/>
+              </a:rPr>
+              <a:t>→ 中心值变动  ΔR = −0.912×10⁻¹⁸（去第 9 段后下移）</a:t>
+            </a:r>
+          </a:p>
+        </p:txBody>
+      </p:sp>
       <p:graphicFrame>
         <p:nvGraphicFramePr>
-          <p:cNvPr id="9" name="Table 8"/>
+          <p:cNvPr id="10" name="Table 9"/>
           <p:cNvGraphicFramePr>
             <a:graphicFrameLocks noGrp="1"/>
           </p:cNvGraphicFramePr>
           <p:nvPr/>
         </p:nvGraphicFramePr>
         <p:xfrm>
-          <a:off x="822960" y="2788920"/>
-          <a:ext cx="10515600" cy="2011680"/>
+          <a:off x="822960" y="4206240"/>
+          <a:ext cx="10515600" cy="1609344"/>
         </p:xfrm>
         <a:graphic>
           <a:graphicData uri="http://schemas.openxmlformats.org/drawingml/2006/table">
@@ -7590,10 +7678,10 @@
                 <a:tableStyleId>{5C22544A-7EE6-4342-B048-85BDC9FD1C3A}</a:tableStyleId>
               </a:tblPr>
               <a:tblGrid>
-                <a:gridCol w="3931920"/>
-                <a:gridCol w="2194560"/>
-                <a:gridCol w="2194560"/>
-                <a:gridCol w="2194560"/>
+                <a:gridCol w="4206240"/>
+                <a:gridCol w="2103120"/>
+                <a:gridCol w="2103120"/>
+                <a:gridCol w="2103120"/>
               </a:tblGrid>
               <a:tr h="402336">
                 <a:tc>
@@ -7632,7 +7720,7 @@
                           </a:solidFill>
                           <a:latin typeface="Arial"/>
                         </a:rPr>
-                        <a:t>17 段（主结果）</a:t>
+                        <a:t>17 段</a:t>
                       </a:r>
                     </a:p>
                   </a:txBody>
@@ -7859,7 +7947,7 @@
                           </a:solidFill>
                           <a:latin typeface="Arial"/>
                         </a:rPr>
-                        <a:t>贝叶斯统计 u（raw, ×10⁻¹⁸）</a:t>
+                        <a:t>贝叶斯额外散布 ξ（raw, ×10⁻¹⁸）</a:t>
                       </a:r>
                     </a:p>
                   </a:txBody>
@@ -7878,7 +7966,7 @@
                           </a:solidFill>
                           <a:latin typeface="Arial"/>
                         </a:rPr>
-                        <a:t>0.800</a:t>
+                        <a:t>2.614</a:t>
                       </a:r>
                     </a:p>
                   </a:txBody>
@@ -7897,7 +7985,7 @@
                           </a:solidFill>
                           <a:latin typeface="Arial"/>
                         </a:rPr>
-                        <a:t>0.546</a:t>
+                        <a:t>0.980</a:t>
                       </a:r>
                     </a:p>
                   </a:txBody>
@@ -7916,85 +8004,7 @@
                           </a:solidFill>
                           <a:latin typeface="Arial"/>
                         </a:rPr>
-                        <a:t>−0.254</a:t>
-                      </a:r>
-                    </a:p>
-                  </a:txBody>
-                  <a:tcPr anchor="ctr" marL="45720" marR="45720" marT="9144" marB="9144"/>
-                </a:tc>
-              </a:tr>
-              <a:tr h="402336">
-                <a:tc>
-                  <a:txBody>
-                    <a:bodyPr wrap="square"/>
-                    <a:lstStyle/>
-                    <a:p>
-                      <a:pPr algn="l"/>
-                      <a:r>
-                        <a:rPr sz="1300" b="1">
-                          <a:solidFill>
-                            <a:srgbClr val="1F1F1F"/>
-                          </a:solidFill>
-                          <a:latin typeface="Arial"/>
-                        </a:rPr>
-                        <a:t>中心值 vs 实验 WLS（raw, ×10⁻¹⁸）</a:t>
-                      </a:r>
-                    </a:p>
-                  </a:txBody>
-                  <a:tcPr anchor="ctr" marL="45720" marR="45720" marT="9144" marB="9144"/>
-                </a:tc>
-                <a:tc>
-                  <a:txBody>
-                    <a:bodyPr wrap="square"/>
-                    <a:lstStyle/>
-                    <a:p>
-                      <a:pPr algn="ctr"/>
-                      <a:r>
-                        <a:rPr sz="1300" b="1">
-                          <a:solidFill>
-                            <a:srgbClr val="1F1F1F"/>
-                          </a:solidFill>
-                          <a:latin typeface="Arial"/>
-                        </a:rPr>
-                        <a:t>−0.016</a:t>
-                      </a:r>
-                    </a:p>
-                  </a:txBody>
-                  <a:tcPr anchor="ctr" marL="45720" marR="45720" marT="9144" marB="9144"/>
-                </a:tc>
-                <a:tc>
-                  <a:txBody>
-                    <a:bodyPr wrap="square"/>
-                    <a:lstStyle/>
-                    <a:p>
-                      <a:pPr algn="ctr"/>
-                      <a:r>
-                        <a:rPr sz="1300" b="1">
-                          <a:solidFill>
-                            <a:srgbClr val="1F1F1F"/>
-                          </a:solidFill>
-                          <a:latin typeface="Arial"/>
-                        </a:rPr>
-                        <a:t>−0.928</a:t>
-                      </a:r>
-                    </a:p>
-                  </a:txBody>
-                  <a:tcPr anchor="ctr" marL="45720" marR="45720" marT="9144" marB="9144"/>
-                </a:tc>
-                <a:tc>
-                  <a:txBody>
-                    <a:bodyPr wrap="square"/>
-                    <a:lstStyle/>
-                    <a:p>
-                      <a:pPr algn="ctr"/>
-                      <a:r>
-                        <a:rPr sz="1300" b="1">
-                          <a:solidFill>
-                            <a:srgbClr val="C0392B"/>
-                          </a:solidFill>
-                          <a:latin typeface="Arial"/>
-                        </a:rPr>
-                        <a:t>−0.912</a:t>
+                        <a:t>−1.634</a:t>
                       </a:r>
                     </a:p>
                   </a:txBody>

</xml_diff>